<commit_message>
Add complete avancement presentation (PoC finished narrative).
</commit_message>
<xml_diff>
--- a/docs/livrables/Presentation-Learning-Analytics.pptx
+++ b/docs/livrables/Presentation-Learning-Analytics.pptx
@@ -17,9 +17,6 @@
     <p:sldId id="265" r:id="rId16"/>
     <p:sldId id="266" r:id="rId17"/>
     <p:sldId id="267" r:id="rId18"/>
-    <p:sldId id="268" r:id="rId19"/>
-    <p:sldId id="269" r:id="rId20"/>
-    <p:sldId id="270" r:id="rId21"/>
   </p:sldIdLst>
   <p:sldSz cx="12191695" cy="6858000" type="screen4x3"/>
   <p:notesSz cx="6858000" cy="9144000"/>
@@ -3196,8 +3193,8 @@
         </p:nvSpPr>
         <p:spPr>
           <a:xfrm>
-            <a:off x="731520" y="2011680"/>
-            <a:ext cx="10515600" cy="1828800"/>
+            <a:off x="731520" y="1828800"/>
+            <a:ext cx="10515600" cy="2286000"/>
           </a:xfrm>
           <a:prstGeom prst="rect">
             <a:avLst/>
@@ -3211,7 +3208,7 @@
           <a:lstStyle/>
           <a:p>
             <a:pPr>
-              <a:defRPr sz="3400" b="1">
+              <a:defRPr sz="3200" b="1">
                 <a:solidFill>
                   <a:srgbClr val="FFFFFF"/>
                 </a:solidFill>
@@ -3232,7 +3229,7 @@
         </p:nvSpPr>
         <p:spPr>
           <a:xfrm>
-            <a:off x="731520" y="5623560"/>
+            <a:off x="731520" y="5577840"/>
             <a:ext cx="10515600" cy="1097280"/>
           </a:xfrm>
           <a:prstGeom prst="rect">
@@ -3250,7 +3247,7 @@
               <a:spcAft>
                 <a:spcPts val="1000"/>
               </a:spcAft>
-              <a:defRPr sz="1600">
+              <a:defRPr sz="1500">
                 <a:solidFill>
                   <a:srgbClr val="FFFFFF"/>
                 </a:solidFill>
@@ -3258,7 +3255,7 @@
               </a:defRPr>
             </a:pPr>
             <a:r>
-              <a:t>Équipe 1 — Cloud Computing I — SIGLIS M1 UPPA</a:t>
+              <a:t>Équipe 1 — Cloud Computing I — SIGLIS M1</a:t>
             </a:r>
           </a:p>
           <a:p>
@@ -3266,7 +3263,7 @@
               <a:spcAft>
                 <a:spcPts val="1000"/>
               </a:spcAft>
-              <a:defRPr sz="1600">
+              <a:defRPr sz="1500">
                 <a:solidFill>
                   <a:srgbClr val="FFFFFF"/>
                 </a:solidFill>
@@ -3282,7 +3279,7 @@
               <a:spcAft>
                 <a:spcPts val="1000"/>
               </a:spcAft>
-              <a:defRPr sz="1600">
+              <a:defRPr sz="1500">
                 <a:solidFill>
                   <a:srgbClr val="FFFFFF"/>
                 </a:solidFill>
@@ -3290,7 +3287,7 @@
               </a:defRPr>
             </a:pPr>
             <a:r>
-              <a:t>Service UNITA / GEMINAE · SaaS · Private cloud EVA</a:t>
+              <a:t>Présentation d’avancement — PoC Docker TERMINÉE</a:t>
             </a:r>
           </a:p>
         </p:txBody>
@@ -3465,7 +3462,7 @@
           <a:lstStyle/>
           <a:p>
             <a:pPr>
-              <a:defRPr sz="3000" b="1">
+              <a:defRPr sz="2800" b="1">
                 <a:solidFill>
                   <a:srgbClr val="FFFFFF"/>
                 </a:solidFill>
@@ -3473,7 +3470,7 @@
               </a:defRPr>
             </a:pPr>
             <a:r>
-              <a:t>API &amp; Dashboard</a:t>
+              <a:t>Ops &amp; contraintes EVA</a:t>
             </a:r>
           </a:p>
         </p:txBody>
@@ -3486,7 +3483,7 @@
         </p:nvSpPr>
         <p:spPr>
           <a:xfrm>
-            <a:off x="822960" y="1737360"/>
+            <a:off x="822960" y="1691640"/>
             <a:ext cx="10515600" cy="4389120"/>
           </a:xfrm>
           <a:prstGeom prst="rect">
@@ -3504,7 +3501,7 @@
               <a:spcAft>
                 <a:spcPts val="1000"/>
               </a:spcAft>
-              <a:defRPr sz="2400">
+              <a:defRPr sz="2200">
                 <a:solidFill>
                   <a:srgbClr val="1A1A1A"/>
                 </a:solidFill>
@@ -3512,7 +3509,7 @@
               </a:defRPr>
             </a:pPr>
             <a:r>
-              <a:t>GET /api/overview — KPIs globaux</a:t>
+              <a:t>1 vCPU / 2 Go RAM → stack allégée</a:t>
             </a:r>
           </a:p>
           <a:p>
@@ -3520,7 +3517,7 @@
               <a:spcAft>
                 <a:spcPts val="1000"/>
               </a:spcAft>
-              <a:defRPr sz="2400">
+              <a:defRPr sz="2200">
                 <a:solidFill>
                   <a:srgbClr val="1A1A1A"/>
                 </a:solidFill>
@@ -3528,7 +3525,7 @@
               </a:defRPr>
             </a:pPr>
             <a:r>
-              <a:t>GET /api/learners — tri par risque</a:t>
+              <a:t>Proxy UPPA + NO_PROXY inter-services</a:t>
             </a:r>
           </a:p>
           <a:p>
@@ -3536,7 +3533,7 @@
               <a:spcAft>
                 <a:spcPts val="1000"/>
               </a:spcAft>
-              <a:defRPr sz="2400">
+              <a:defRPr sz="2200">
                 <a:solidFill>
                   <a:srgbClr val="1A1A1A"/>
                 </a:solidFill>
@@ -3544,7 +3541,7 @@
               </a:defRPr>
             </a:pPr>
             <a:r>
-              <a:t>GET /api/remediations — suggestions</a:t>
+              <a:t>restart: on-failure:3 (pas de boucle illimitée)</a:t>
             </a:r>
           </a:p>
           <a:p>
@@ -3552,7 +3549,7 @@
               <a:spcAft>
                 <a:spcPts val="1000"/>
               </a:spcAft>
-              <a:defRPr sz="2400">
+              <a:defRPr sz="2200">
                 <a:solidFill>
                   <a:srgbClr val="1A1A1A"/>
                 </a:solidFill>
@@ -3560,7 +3557,7 @@
               </a:defRPr>
             </a:pPr>
             <a:r>
-              <a:t>Dashboard : http://localhost:8300</a:t>
+              <a:t>OpenVPN obligatoire pour accéder à la VM</a:t>
             </a:r>
           </a:p>
         </p:txBody>
@@ -3596,7 +3593,7 @@
               </a:defRPr>
             </a:pPr>
             <a:r>
-              <a:t>Équipe 1 · Learning Analytics · Cloud Computing I  |  9/14</a:t>
+              <a:t>Équipe 1 · Avancement · PoC terminée  |  9/11</a:t>
             </a:r>
           </a:p>
         </p:txBody>
@@ -3771,7 +3768,7 @@
           <a:lstStyle/>
           <a:p>
             <a:pPr>
-              <a:defRPr sz="3000" b="1">
+              <a:defRPr sz="2800" b="1">
                 <a:solidFill>
                   <a:srgbClr val="FFFFFF"/>
                 </a:solidFill>
@@ -3779,7 +3776,7 @@
               </a:defRPr>
             </a:pPr>
             <a:r>
-              <a:t>Résultats PoC</a:t>
+              <a:t>Roadmap</a:t>
             </a:r>
           </a:p>
         </p:txBody>
@@ -3792,7 +3789,7 @@
         </p:nvSpPr>
         <p:spPr>
           <a:xfrm>
-            <a:off x="822960" y="1737360"/>
+            <a:off x="822960" y="1691640"/>
             <a:ext cx="10515600" cy="4389120"/>
           </a:xfrm>
           <a:prstGeom prst="rect">
@@ -3810,7 +3807,7 @@
               <a:spcAft>
                 <a:spcPts val="1000"/>
               </a:spcAft>
-              <a:defRPr sz="2400">
+              <a:defRPr sz="2200">
                 <a:solidFill>
                   <a:srgbClr val="1A1A1A"/>
                 </a:solidFill>
@@ -3818,7 +3815,7 @@
               </a:defRPr>
             </a:pPr>
             <a:r>
-              <a:t>~2300 statements xAPI</a:t>
+              <a:t>✓ Problème, solution, Docker PoC</a:t>
             </a:r>
           </a:p>
           <a:p>
@@ -3826,7 +3823,7 @@
               <a:spcAft>
                 <a:spcPts val="1000"/>
               </a:spcAft>
-              <a:defRPr sz="2400">
+              <a:defRPr sz="2200">
                 <a:solidFill>
                   <a:srgbClr val="1A1A1A"/>
                 </a:solidFill>
@@ -3834,7 +3831,7 @@
               </a:defRPr>
             </a:pPr>
             <a:r>
-              <a:t>25 apprenants simulés</a:t>
+              <a:t>✓ Démo locale + EVA documentée</a:t>
             </a:r>
           </a:p>
           <a:p>
@@ -3842,7 +3839,7 @@
               <a:spcAft>
                 <a:spcPts val="1000"/>
               </a:spcAft>
-              <a:defRPr sz="2400">
+              <a:defRPr sz="2200">
                 <a:solidFill>
                   <a:srgbClr val="1A1A1A"/>
                 </a:solidFill>
@@ -3850,7 +3847,7 @@
               </a:defRPr>
             </a:pPr>
             <a:r>
-              <a:t>Apprenants at risk identifiés</a:t>
+              <a:t>→ Soutenance finale : BMC, ArchiMate, cookbook, slides finales</a:t>
             </a:r>
           </a:p>
           <a:p>
@@ -3858,7 +3855,7 @@
               <a:spcAft>
                 <a:spcPts val="1000"/>
               </a:spcAft>
-              <a:defRPr sz="2400">
+              <a:defRPr sz="2200">
                 <a:solidFill>
                   <a:srgbClr val="1A1A1A"/>
                 </a:solidFill>
@@ -3866,7 +3863,7 @@
               </a:defRPr>
             </a:pPr>
             <a:r>
-              <a:t>Smoke test automatisé : PASSED</a:t>
+              <a:t>Perspectives : LMS réel, RGPD, Swarm/K8s</a:t>
             </a:r>
           </a:p>
         </p:txBody>
@@ -3902,7 +3899,7 @@
               </a:defRPr>
             </a:pPr>
             <a:r>
-              <a:t>Équipe 1 · Learning Analytics · Cloud Computing I  |  10/14</a:t>
+              <a:t>Équipe 1 · Avancement · PoC terminée  |  10/11</a:t>
             </a:r>
           </a:p>
         </p:txBody>
@@ -4077,7 +4074,7 @@
           <a:lstStyle/>
           <a:p>
             <a:pPr>
-              <a:defRPr sz="3000" b="1">
+              <a:defRPr sz="2800" b="1">
                 <a:solidFill>
                   <a:srgbClr val="FFFFFF"/>
                 </a:solidFill>
@@ -4085,7 +4082,7 @@
               </a:defRPr>
             </a:pPr>
             <a:r>
-              <a:t>SLA &amp; sécurité</a:t>
+              <a:t>Merci — questions ?</a:t>
             </a:r>
           </a:p>
         </p:txBody>
@@ -4098,7 +4095,7 @@
         </p:nvSpPr>
         <p:spPr>
           <a:xfrm>
-            <a:off x="822960" y="1737360"/>
+            <a:off x="822960" y="1691640"/>
             <a:ext cx="10515600" cy="4389120"/>
           </a:xfrm>
           <a:prstGeom prst="rect">
@@ -4116,7 +4113,7 @@
               <a:spcAft>
                 <a:spcPts val="1000"/>
               </a:spcAft>
-              <a:defRPr sz="2400">
+              <a:defRPr sz="2200">
                 <a:solidFill>
                   <a:srgbClr val="1A1A1A"/>
                 </a:solidFill>
@@ -4124,7 +4121,7 @@
               </a:defRPr>
             </a:pPr>
             <a:r>
-              <a:t>Tiers FREE / GOLD / PLATINUM</a:t>
+              <a:t>GitHub : github.com/galaxie44/learning-analytics-educational-processes</a:t>
             </a:r>
           </a:p>
           <a:p>
@@ -4132,7 +4129,7 @@
               <a:spcAft>
                 <a:spcPts val="1000"/>
               </a:spcAft>
-              <a:defRPr sz="2400">
+              <a:defRPr sz="2200">
                 <a:solidFill>
                   <a:srgbClr val="1A1A1A"/>
                 </a:solidFill>
@@ -4140,39 +4137,7 @@
               </a:defRPr>
             </a:pPr>
             <a:r>
-              <a:t>Healthchecks + restart policies</a:t>
-            </a:r>
-          </a:p>
-          <a:p>
-            <a:pPr>
-              <a:spcAft>
-                <a:spcPts val="1000"/>
-              </a:spcAft>
-              <a:defRPr sz="2400">
-                <a:solidFill>
-                  <a:srgbClr val="1A1A1A"/>
-                </a:solidFill>
-                <a:latin typeface="Calibri"/>
-              </a:defRPr>
-            </a:pPr>
-            <a:r>
-              <a:t>Auth Basic sur le LRS</a:t>
-            </a:r>
-          </a:p>
-          <a:p>
-            <a:pPr>
-              <a:spcAft>
-                <a:spcPts val="1000"/>
-              </a:spcAft>
-              <a:defRPr sz="2400">
-                <a:solidFill>
-                  <a:srgbClr val="1A1A1A"/>
-                </a:solidFill>
-                <a:latin typeface="Calibri"/>
-              </a:defRPr>
-            </a:pPr>
-            <a:r>
-              <a:t>Données synthétiques (confidentialité)</a:t>
+              <a:t>Équipe 1 · Learning Analytics · Cloud Computing I</a:t>
             </a:r>
           </a:p>
         </p:txBody>
@@ -4208,893 +4173,7 @@
               </a:defRPr>
             </a:pPr>
             <a:r>
-              <a:t>Équipe 1 · Learning Analytics · Cloud Computing I  |  11/14</a:t>
-            </a:r>
-          </a:p>
-        </p:txBody>
-      </p:sp>
-    </p:spTree>
-  </p:cSld>
-  <p:clrMapOvr>
-    <a:masterClrMapping/>
-  </p:clrMapOvr>
-</p:sld>
-</file>
-
-<file path=ppt/slides/slide13.xml><?xml version="1.0" encoding="utf-8"?>
-<p:sld xmlns:a="http://schemas.openxmlformats.org/drawingml/2006/main" xmlns:p="http://schemas.openxmlformats.org/presentationml/2006/main" xmlns:r="http://schemas.openxmlformats.org/officeDocument/2006/relationships">
-  <p:cSld>
-    <p:spTree>
-      <p:nvGrpSpPr>
-        <p:cNvPr id="1" name=""/>
-        <p:cNvGrpSpPr/>
-        <p:nvPr/>
-      </p:nvGrpSpPr>
-      <p:grpSpPr/>
-      <p:sp>
-        <p:nvSpPr>
-          <p:cNvPr id="2" name="Rectangle 1"/>
-          <p:cNvSpPr/>
-          <p:nvPr/>
-        </p:nvSpPr>
-        <p:spPr>
-          <a:xfrm>
-            <a:off x="0" y="0"/>
-            <a:ext cx="12191695" cy="6858000"/>
-          </a:xfrm>
-          <a:prstGeom prst="rect">
-            <a:avLst/>
-          </a:prstGeom>
-          <a:solidFill>
-            <a:srgbClr val="F4F7FA"/>
-          </a:solidFill>
-          <a:ln>
-            <a:noFill/>
-          </a:ln>
-        </p:spPr>
-        <p:style>
-          <a:lnRef idx="1">
-            <a:schemeClr val="accent1"/>
-          </a:lnRef>
-          <a:fillRef idx="3">
-            <a:schemeClr val="accent1"/>
-          </a:fillRef>
-          <a:effectRef idx="2">
-            <a:schemeClr val="accent1"/>
-          </a:effectRef>
-          <a:fontRef idx="minor">
-            <a:schemeClr val="lt1"/>
-          </a:fontRef>
-        </p:style>
-        <p:txBody>
-          <a:bodyPr rtlCol="0" anchor="ctr"/>
-          <a:lstStyle/>
-          <a:p>
-            <a:pPr algn="ctr"/>
-          </a:p>
-        </p:txBody>
-      </p:sp>
-      <p:sp>
-        <p:nvSpPr>
-          <p:cNvPr id="3" name="Rectangle 2"/>
-          <p:cNvSpPr/>
-          <p:nvPr/>
-        </p:nvSpPr>
-        <p:spPr>
-          <a:xfrm>
-            <a:off x="0" y="0"/>
-            <a:ext cx="164592" cy="6858000"/>
-          </a:xfrm>
-          <a:prstGeom prst="rect">
-            <a:avLst/>
-          </a:prstGeom>
-          <a:solidFill>
-            <a:srgbClr val="1F6F8B"/>
-          </a:solidFill>
-          <a:ln>
-            <a:noFill/>
-          </a:ln>
-        </p:spPr>
-        <p:style>
-          <a:lnRef idx="1">
-            <a:schemeClr val="accent1"/>
-          </a:lnRef>
-          <a:fillRef idx="3">
-            <a:schemeClr val="accent1"/>
-          </a:fillRef>
-          <a:effectRef idx="2">
-            <a:schemeClr val="accent1"/>
-          </a:effectRef>
-          <a:fontRef idx="minor">
-            <a:schemeClr val="lt1"/>
-          </a:fontRef>
-        </p:style>
-        <p:txBody>
-          <a:bodyPr rtlCol="0" anchor="ctr"/>
-          <a:lstStyle/>
-          <a:p>
-            <a:pPr algn="ctr"/>
-          </a:p>
-        </p:txBody>
-      </p:sp>
-      <p:sp>
-        <p:nvSpPr>
-          <p:cNvPr id="4" name="Rectangle 3"/>
-          <p:cNvSpPr/>
-          <p:nvPr/>
-        </p:nvSpPr>
-        <p:spPr>
-          <a:xfrm>
-            <a:off x="0" y="0"/>
-            <a:ext cx="12191695" cy="1234440"/>
-          </a:xfrm>
-          <a:prstGeom prst="rect">
-            <a:avLst/>
-          </a:prstGeom>
-          <a:solidFill>
-            <a:srgbClr val="0F2C4C"/>
-          </a:solidFill>
-          <a:ln>
-            <a:noFill/>
-          </a:ln>
-        </p:spPr>
-        <p:style>
-          <a:lnRef idx="1">
-            <a:schemeClr val="accent1"/>
-          </a:lnRef>
-          <a:fillRef idx="3">
-            <a:schemeClr val="accent1"/>
-          </a:fillRef>
-          <a:effectRef idx="2">
-            <a:schemeClr val="accent1"/>
-          </a:effectRef>
-          <a:fontRef idx="minor">
-            <a:schemeClr val="lt1"/>
-          </a:fontRef>
-        </p:style>
-        <p:txBody>
-          <a:bodyPr rtlCol="0" anchor="ctr"/>
-          <a:lstStyle/>
-          <a:p>
-            <a:pPr algn="ctr"/>
-          </a:p>
-        </p:txBody>
-      </p:sp>
-      <p:sp>
-        <p:nvSpPr>
-          <p:cNvPr id="5" name="TextBox 4"/>
-          <p:cNvSpPr txBox="1"/>
-          <p:nvPr/>
-        </p:nvSpPr>
-        <p:spPr>
-          <a:xfrm>
-            <a:off x="640080" y="320040"/>
-            <a:ext cx="10972800" cy="731520"/>
-          </a:xfrm>
-          <a:prstGeom prst="rect">
-            <a:avLst/>
-          </a:prstGeom>
-          <a:noFill/>
-        </p:spPr>
-        <p:txBody>
-          <a:bodyPr wrap="none">
-            <a:spAutoFit/>
-          </a:bodyPr>
-          <a:lstStyle/>
-          <a:p>
-            <a:pPr>
-              <a:defRPr sz="3000" b="1">
-                <a:solidFill>
-                  <a:srgbClr val="FFFFFF"/>
-                </a:solidFill>
-                <a:latin typeface="Calibri"/>
-              </a:defRPr>
-            </a:pPr>
-            <a:r>
-              <a:t>Contraintes EVA</a:t>
-            </a:r>
-          </a:p>
-        </p:txBody>
-      </p:sp>
-      <p:sp>
-        <p:nvSpPr>
-          <p:cNvPr id="6" name="TextBox 5"/>
-          <p:cNvSpPr txBox="1"/>
-          <p:nvPr/>
-        </p:nvSpPr>
-        <p:spPr>
-          <a:xfrm>
-            <a:off x="822960" y="1737360"/>
-            <a:ext cx="10515600" cy="4389120"/>
-          </a:xfrm>
-          <a:prstGeom prst="rect">
-            <a:avLst/>
-          </a:prstGeom>
-          <a:noFill/>
-        </p:spPr>
-        <p:txBody>
-          <a:bodyPr wrap="none">
-            <a:spAutoFit/>
-          </a:bodyPr>
-          <a:lstStyle/>
-          <a:p>
-            <a:pPr>
-              <a:spcAft>
-                <a:spcPts val="1000"/>
-              </a:spcAft>
-              <a:defRPr sz="2400">
-                <a:solidFill>
-                  <a:srgbClr val="1A1A1A"/>
-                </a:solidFill>
-                <a:latin typeface="Calibri"/>
-              </a:defRPr>
-            </a:pPr>
-            <a:r>
-              <a:t>1 vCPU / 2 Go RAM → stack allégée</a:t>
-            </a:r>
-          </a:p>
-          <a:p>
-            <a:pPr>
-              <a:spcAft>
-                <a:spcPts val="1000"/>
-              </a:spcAft>
-              <a:defRPr sz="2400">
-                <a:solidFill>
-                  <a:srgbClr val="1A1A1A"/>
-                </a:solidFill>
-                <a:latin typeface="Calibri"/>
-              </a:defRPr>
-            </a:pPr>
-            <a:r>
-              <a:t>Proxy UPPA + NO_PROXY inter-services</a:t>
-            </a:r>
-          </a:p>
-          <a:p>
-            <a:pPr>
-              <a:spcAft>
-                <a:spcPts val="1000"/>
-              </a:spcAft>
-              <a:defRPr sz="2400">
-                <a:solidFill>
-                  <a:srgbClr val="1A1A1A"/>
-                </a:solidFill>
-                <a:latin typeface="Calibri"/>
-              </a:defRPr>
-            </a:pPr>
-            <a:r>
-              <a:t>OpenVPN obligatoire pour la démo</a:t>
-            </a:r>
-          </a:p>
-        </p:txBody>
-      </p:sp>
-      <p:sp>
-        <p:nvSpPr>
-          <p:cNvPr id="7" name="TextBox 6"/>
-          <p:cNvSpPr txBox="1"/>
-          <p:nvPr/>
-        </p:nvSpPr>
-        <p:spPr>
-          <a:xfrm>
-            <a:off x="640080" y="6309360"/>
-            <a:ext cx="10972800" cy="365760"/>
-          </a:xfrm>
-          <a:prstGeom prst="rect">
-            <a:avLst/>
-          </a:prstGeom>
-          <a:noFill/>
-        </p:spPr>
-        <p:txBody>
-          <a:bodyPr wrap="none">
-            <a:spAutoFit/>
-          </a:bodyPr>
-          <a:lstStyle/>
-          <a:p>
-            <a:pPr>
-              <a:defRPr sz="1200">
-                <a:solidFill>
-                  <a:srgbClr val="4A5568"/>
-                </a:solidFill>
-                <a:latin typeface="Calibri"/>
-              </a:defRPr>
-            </a:pPr>
-            <a:r>
-              <a:t>Équipe 1 · Learning Analytics · Cloud Computing I  |  12/14</a:t>
-            </a:r>
-          </a:p>
-        </p:txBody>
-      </p:sp>
-    </p:spTree>
-  </p:cSld>
-  <p:clrMapOvr>
-    <a:masterClrMapping/>
-  </p:clrMapOvr>
-</p:sld>
-</file>
-
-<file path=ppt/slides/slide14.xml><?xml version="1.0" encoding="utf-8"?>
-<p:sld xmlns:a="http://schemas.openxmlformats.org/drawingml/2006/main" xmlns:p="http://schemas.openxmlformats.org/presentationml/2006/main" xmlns:r="http://schemas.openxmlformats.org/officeDocument/2006/relationships">
-  <p:cSld>
-    <p:spTree>
-      <p:nvGrpSpPr>
-        <p:cNvPr id="1" name=""/>
-        <p:cNvGrpSpPr/>
-        <p:nvPr/>
-      </p:nvGrpSpPr>
-      <p:grpSpPr/>
-      <p:sp>
-        <p:nvSpPr>
-          <p:cNvPr id="2" name="Rectangle 1"/>
-          <p:cNvSpPr/>
-          <p:nvPr/>
-        </p:nvSpPr>
-        <p:spPr>
-          <a:xfrm>
-            <a:off x="0" y="0"/>
-            <a:ext cx="12191695" cy="6858000"/>
-          </a:xfrm>
-          <a:prstGeom prst="rect">
-            <a:avLst/>
-          </a:prstGeom>
-          <a:solidFill>
-            <a:srgbClr val="F4F7FA"/>
-          </a:solidFill>
-          <a:ln>
-            <a:noFill/>
-          </a:ln>
-        </p:spPr>
-        <p:style>
-          <a:lnRef idx="1">
-            <a:schemeClr val="accent1"/>
-          </a:lnRef>
-          <a:fillRef idx="3">
-            <a:schemeClr val="accent1"/>
-          </a:fillRef>
-          <a:effectRef idx="2">
-            <a:schemeClr val="accent1"/>
-          </a:effectRef>
-          <a:fontRef idx="minor">
-            <a:schemeClr val="lt1"/>
-          </a:fontRef>
-        </p:style>
-        <p:txBody>
-          <a:bodyPr rtlCol="0" anchor="ctr"/>
-          <a:lstStyle/>
-          <a:p>
-            <a:pPr algn="ctr"/>
-          </a:p>
-        </p:txBody>
-      </p:sp>
-      <p:sp>
-        <p:nvSpPr>
-          <p:cNvPr id="3" name="Rectangle 2"/>
-          <p:cNvSpPr/>
-          <p:nvPr/>
-        </p:nvSpPr>
-        <p:spPr>
-          <a:xfrm>
-            <a:off x="0" y="0"/>
-            <a:ext cx="164592" cy="6858000"/>
-          </a:xfrm>
-          <a:prstGeom prst="rect">
-            <a:avLst/>
-          </a:prstGeom>
-          <a:solidFill>
-            <a:srgbClr val="1F6F8B"/>
-          </a:solidFill>
-          <a:ln>
-            <a:noFill/>
-          </a:ln>
-        </p:spPr>
-        <p:style>
-          <a:lnRef idx="1">
-            <a:schemeClr val="accent1"/>
-          </a:lnRef>
-          <a:fillRef idx="3">
-            <a:schemeClr val="accent1"/>
-          </a:fillRef>
-          <a:effectRef idx="2">
-            <a:schemeClr val="accent1"/>
-          </a:effectRef>
-          <a:fontRef idx="minor">
-            <a:schemeClr val="lt1"/>
-          </a:fontRef>
-        </p:style>
-        <p:txBody>
-          <a:bodyPr rtlCol="0" anchor="ctr"/>
-          <a:lstStyle/>
-          <a:p>
-            <a:pPr algn="ctr"/>
-          </a:p>
-        </p:txBody>
-      </p:sp>
-      <p:sp>
-        <p:nvSpPr>
-          <p:cNvPr id="4" name="Rectangle 3"/>
-          <p:cNvSpPr/>
-          <p:nvPr/>
-        </p:nvSpPr>
-        <p:spPr>
-          <a:xfrm>
-            <a:off x="0" y="0"/>
-            <a:ext cx="12191695" cy="1234440"/>
-          </a:xfrm>
-          <a:prstGeom prst="rect">
-            <a:avLst/>
-          </a:prstGeom>
-          <a:solidFill>
-            <a:srgbClr val="0F2C4C"/>
-          </a:solidFill>
-          <a:ln>
-            <a:noFill/>
-          </a:ln>
-        </p:spPr>
-        <p:style>
-          <a:lnRef idx="1">
-            <a:schemeClr val="accent1"/>
-          </a:lnRef>
-          <a:fillRef idx="3">
-            <a:schemeClr val="accent1"/>
-          </a:fillRef>
-          <a:effectRef idx="2">
-            <a:schemeClr val="accent1"/>
-          </a:effectRef>
-          <a:fontRef idx="minor">
-            <a:schemeClr val="lt1"/>
-          </a:fontRef>
-        </p:style>
-        <p:txBody>
-          <a:bodyPr rtlCol="0" anchor="ctr"/>
-          <a:lstStyle/>
-          <a:p>
-            <a:pPr algn="ctr"/>
-          </a:p>
-        </p:txBody>
-      </p:sp>
-      <p:sp>
-        <p:nvSpPr>
-          <p:cNvPr id="5" name="TextBox 4"/>
-          <p:cNvSpPr txBox="1"/>
-          <p:nvPr/>
-        </p:nvSpPr>
-        <p:spPr>
-          <a:xfrm>
-            <a:off x="640080" y="320040"/>
-            <a:ext cx="10972800" cy="731520"/>
-          </a:xfrm>
-          <a:prstGeom prst="rect">
-            <a:avLst/>
-          </a:prstGeom>
-          <a:noFill/>
-        </p:spPr>
-        <p:txBody>
-          <a:bodyPr wrap="none">
-            <a:spAutoFit/>
-          </a:bodyPr>
-          <a:lstStyle/>
-          <a:p>
-            <a:pPr>
-              <a:defRPr sz="3000" b="1">
-                <a:solidFill>
-                  <a:srgbClr val="FFFFFF"/>
-                </a:solidFill>
-                <a:latin typeface="Calibri"/>
-              </a:defRPr>
-            </a:pPr>
-            <a:r>
-              <a:t>Business Model Canvas (synthèse)</a:t>
-            </a:r>
-          </a:p>
-        </p:txBody>
-      </p:sp>
-      <p:sp>
-        <p:nvSpPr>
-          <p:cNvPr id="6" name="TextBox 5"/>
-          <p:cNvSpPr txBox="1"/>
-          <p:nvPr/>
-        </p:nvSpPr>
-        <p:spPr>
-          <a:xfrm>
-            <a:off x="822960" y="1737360"/>
-            <a:ext cx="10515600" cy="4389120"/>
-          </a:xfrm>
-          <a:prstGeom prst="rect">
-            <a:avLst/>
-          </a:prstGeom>
-          <a:noFill/>
-        </p:spPr>
-        <p:txBody>
-          <a:bodyPr wrap="none">
-            <a:spAutoFit/>
-          </a:bodyPr>
-          <a:lstStyle/>
-          <a:p>
-            <a:pPr>
-              <a:spcAft>
-                <a:spcPts val="1000"/>
-              </a:spcAft>
-              <a:defRPr sz="2400">
-                <a:solidFill>
-                  <a:srgbClr val="1A1A1A"/>
-                </a:solidFill>
-                <a:latin typeface="Calibri"/>
-              </a:defRPr>
-            </a:pPr>
-            <a:r>
-              <a:t>Valeur : détection précoce + remédiation</a:t>
-            </a:r>
-          </a:p>
-          <a:p>
-            <a:pPr>
-              <a:spcAft>
-                <a:spcPts val="1000"/>
-              </a:spcAft>
-              <a:defRPr sz="2400">
-                <a:solidFill>
-                  <a:srgbClr val="1A1A1A"/>
-                </a:solidFill>
-                <a:latin typeface="Calibri"/>
-              </a:defRPr>
-            </a:pPr>
-            <a:r>
-              <a:t>Clients : enseignants / établissements UNITA</a:t>
-            </a:r>
-          </a:p>
-          <a:p>
-            <a:pPr>
-              <a:spcAft>
-                <a:spcPts val="1000"/>
-              </a:spcAft>
-              <a:defRPr sz="2400">
-                <a:solidFill>
-                  <a:srgbClr val="1A1A1A"/>
-                </a:solidFill>
-                <a:latin typeface="Calibri"/>
-              </a:defRPr>
-            </a:pPr>
-            <a:r>
-              <a:t>Canal : dashboard + API</a:t>
-            </a:r>
-          </a:p>
-          <a:p>
-            <a:pPr>
-              <a:spcAft>
-                <a:spcPts val="1000"/>
-              </a:spcAft>
-              <a:defRPr sz="2400">
-                <a:solidFill>
-                  <a:srgbClr val="1A1A1A"/>
-                </a:solidFill>
-                <a:latin typeface="Calibri"/>
-              </a:defRPr>
-            </a:pPr>
-            <a:r>
-              <a:t>Revenus : freemium FREE / GOLD / PLATINUM</a:t>
-            </a:r>
-          </a:p>
-        </p:txBody>
-      </p:sp>
-      <p:sp>
-        <p:nvSpPr>
-          <p:cNvPr id="7" name="TextBox 6"/>
-          <p:cNvSpPr txBox="1"/>
-          <p:nvPr/>
-        </p:nvSpPr>
-        <p:spPr>
-          <a:xfrm>
-            <a:off x="640080" y="6309360"/>
-            <a:ext cx="10972800" cy="365760"/>
-          </a:xfrm>
-          <a:prstGeom prst="rect">
-            <a:avLst/>
-          </a:prstGeom>
-          <a:noFill/>
-        </p:spPr>
-        <p:txBody>
-          <a:bodyPr wrap="none">
-            <a:spAutoFit/>
-          </a:bodyPr>
-          <a:lstStyle/>
-          <a:p>
-            <a:pPr>
-              <a:defRPr sz="1200">
-                <a:solidFill>
-                  <a:srgbClr val="4A5568"/>
-                </a:solidFill>
-                <a:latin typeface="Calibri"/>
-              </a:defRPr>
-            </a:pPr>
-            <a:r>
-              <a:t>Équipe 1 · Learning Analytics · Cloud Computing I  |  13/14</a:t>
-            </a:r>
-          </a:p>
-        </p:txBody>
-      </p:sp>
-    </p:spTree>
-  </p:cSld>
-  <p:clrMapOvr>
-    <a:masterClrMapping/>
-  </p:clrMapOvr>
-</p:sld>
-</file>
-
-<file path=ppt/slides/slide15.xml><?xml version="1.0" encoding="utf-8"?>
-<p:sld xmlns:a="http://schemas.openxmlformats.org/drawingml/2006/main" xmlns:p="http://schemas.openxmlformats.org/presentationml/2006/main" xmlns:r="http://schemas.openxmlformats.org/officeDocument/2006/relationships">
-  <p:cSld>
-    <p:spTree>
-      <p:nvGrpSpPr>
-        <p:cNvPr id="1" name=""/>
-        <p:cNvGrpSpPr/>
-        <p:nvPr/>
-      </p:nvGrpSpPr>
-      <p:grpSpPr/>
-      <p:sp>
-        <p:nvSpPr>
-          <p:cNvPr id="2" name="Rectangle 1"/>
-          <p:cNvSpPr/>
-          <p:nvPr/>
-        </p:nvSpPr>
-        <p:spPr>
-          <a:xfrm>
-            <a:off x="0" y="0"/>
-            <a:ext cx="12191695" cy="6858000"/>
-          </a:xfrm>
-          <a:prstGeom prst="rect">
-            <a:avLst/>
-          </a:prstGeom>
-          <a:solidFill>
-            <a:srgbClr val="F4F7FA"/>
-          </a:solidFill>
-          <a:ln>
-            <a:noFill/>
-          </a:ln>
-        </p:spPr>
-        <p:style>
-          <a:lnRef idx="1">
-            <a:schemeClr val="accent1"/>
-          </a:lnRef>
-          <a:fillRef idx="3">
-            <a:schemeClr val="accent1"/>
-          </a:fillRef>
-          <a:effectRef idx="2">
-            <a:schemeClr val="accent1"/>
-          </a:effectRef>
-          <a:fontRef idx="minor">
-            <a:schemeClr val="lt1"/>
-          </a:fontRef>
-        </p:style>
-        <p:txBody>
-          <a:bodyPr rtlCol="0" anchor="ctr"/>
-          <a:lstStyle/>
-          <a:p>
-            <a:pPr algn="ctr"/>
-          </a:p>
-        </p:txBody>
-      </p:sp>
-      <p:sp>
-        <p:nvSpPr>
-          <p:cNvPr id="3" name="Rectangle 2"/>
-          <p:cNvSpPr/>
-          <p:nvPr/>
-        </p:nvSpPr>
-        <p:spPr>
-          <a:xfrm>
-            <a:off x="0" y="0"/>
-            <a:ext cx="164592" cy="6858000"/>
-          </a:xfrm>
-          <a:prstGeom prst="rect">
-            <a:avLst/>
-          </a:prstGeom>
-          <a:solidFill>
-            <a:srgbClr val="1F6F8B"/>
-          </a:solidFill>
-          <a:ln>
-            <a:noFill/>
-          </a:ln>
-        </p:spPr>
-        <p:style>
-          <a:lnRef idx="1">
-            <a:schemeClr val="accent1"/>
-          </a:lnRef>
-          <a:fillRef idx="3">
-            <a:schemeClr val="accent1"/>
-          </a:fillRef>
-          <a:effectRef idx="2">
-            <a:schemeClr val="accent1"/>
-          </a:effectRef>
-          <a:fontRef idx="minor">
-            <a:schemeClr val="lt1"/>
-          </a:fontRef>
-        </p:style>
-        <p:txBody>
-          <a:bodyPr rtlCol="0" anchor="ctr"/>
-          <a:lstStyle/>
-          <a:p>
-            <a:pPr algn="ctr"/>
-          </a:p>
-        </p:txBody>
-      </p:sp>
-      <p:sp>
-        <p:nvSpPr>
-          <p:cNvPr id="4" name="Rectangle 3"/>
-          <p:cNvSpPr/>
-          <p:nvPr/>
-        </p:nvSpPr>
-        <p:spPr>
-          <a:xfrm>
-            <a:off x="0" y="0"/>
-            <a:ext cx="12191695" cy="1234440"/>
-          </a:xfrm>
-          <a:prstGeom prst="rect">
-            <a:avLst/>
-          </a:prstGeom>
-          <a:solidFill>
-            <a:srgbClr val="0F2C4C"/>
-          </a:solidFill>
-          <a:ln>
-            <a:noFill/>
-          </a:ln>
-        </p:spPr>
-        <p:style>
-          <a:lnRef idx="1">
-            <a:schemeClr val="accent1"/>
-          </a:lnRef>
-          <a:fillRef idx="3">
-            <a:schemeClr val="accent1"/>
-          </a:fillRef>
-          <a:effectRef idx="2">
-            <a:schemeClr val="accent1"/>
-          </a:effectRef>
-          <a:fontRef idx="minor">
-            <a:schemeClr val="lt1"/>
-          </a:fontRef>
-        </p:style>
-        <p:txBody>
-          <a:bodyPr rtlCol="0" anchor="ctr"/>
-          <a:lstStyle/>
-          <a:p>
-            <a:pPr algn="ctr"/>
-          </a:p>
-        </p:txBody>
-      </p:sp>
-      <p:sp>
-        <p:nvSpPr>
-          <p:cNvPr id="5" name="TextBox 4"/>
-          <p:cNvSpPr txBox="1"/>
-          <p:nvPr/>
-        </p:nvSpPr>
-        <p:spPr>
-          <a:xfrm>
-            <a:off x="640080" y="320040"/>
-            <a:ext cx="10972800" cy="731520"/>
-          </a:xfrm>
-          <a:prstGeom prst="rect">
-            <a:avLst/>
-          </a:prstGeom>
-          <a:noFill/>
-        </p:spPr>
-        <p:txBody>
-          <a:bodyPr wrap="none">
-            <a:spAutoFit/>
-          </a:bodyPr>
-          <a:lstStyle/>
-          <a:p>
-            <a:pPr>
-              <a:defRPr sz="3000" b="1">
-                <a:solidFill>
-                  <a:srgbClr val="FFFFFF"/>
-                </a:solidFill>
-                <a:latin typeface="Calibri"/>
-              </a:defRPr>
-            </a:pPr>
-            <a:r>
-              <a:t>Conclusion &amp; perspectives</a:t>
-            </a:r>
-          </a:p>
-        </p:txBody>
-      </p:sp>
-      <p:sp>
-        <p:nvSpPr>
-          <p:cNvPr id="6" name="TextBox 5"/>
-          <p:cNvSpPr txBox="1"/>
-          <p:nvPr/>
-        </p:nvSpPr>
-        <p:spPr>
-          <a:xfrm>
-            <a:off x="822960" y="1737360"/>
-            <a:ext cx="10515600" cy="4389120"/>
-          </a:xfrm>
-          <a:prstGeom prst="rect">
-            <a:avLst/>
-          </a:prstGeom>
-          <a:noFill/>
-        </p:spPr>
-        <p:txBody>
-          <a:bodyPr wrap="none">
-            <a:spAutoFit/>
-          </a:bodyPr>
-          <a:lstStyle/>
-          <a:p>
-            <a:pPr>
-              <a:spcAft>
-                <a:spcPts val="1000"/>
-              </a:spcAft>
-              <a:defRPr sz="2400">
-                <a:solidFill>
-                  <a:srgbClr val="1A1A1A"/>
-                </a:solidFill>
-                <a:latin typeface="Calibri"/>
-              </a:defRPr>
-            </a:pPr>
-            <a:r>
-              <a:t>PoC Docker local + EVA opérationnel</a:t>
-            </a:r>
-          </a:p>
-          <a:p>
-            <a:pPr>
-              <a:spcAft>
-                <a:spcPts val="1000"/>
-              </a:spcAft>
-              <a:defRPr sz="2400">
-                <a:solidFill>
-                  <a:srgbClr val="1A1A1A"/>
-                </a:solidFill>
-                <a:latin typeface="Calibri"/>
-              </a:defRPr>
-            </a:pPr>
-            <a:r>
-              <a:t>Perspectives : LMS réel, RGPD, Swarm/K8s</a:t>
-            </a:r>
-          </a:p>
-          <a:p>
-            <a:pPr>
-              <a:spcAft>
-                <a:spcPts val="1000"/>
-              </a:spcAft>
-              <a:defRPr sz="2400">
-                <a:solidFill>
-                  <a:srgbClr val="1A1A1A"/>
-                </a:solidFill>
-                <a:latin typeface="Calibri"/>
-              </a:defRPr>
-            </a:pPr>
-            <a:r>
-              <a:t>Merci — questions ?</a:t>
-            </a:r>
-          </a:p>
-        </p:txBody>
-      </p:sp>
-      <p:sp>
-        <p:nvSpPr>
-          <p:cNvPr id="7" name="TextBox 6"/>
-          <p:cNvSpPr txBox="1"/>
-          <p:nvPr/>
-        </p:nvSpPr>
-        <p:spPr>
-          <a:xfrm>
-            <a:off x="640080" y="6309360"/>
-            <a:ext cx="10972800" cy="365760"/>
-          </a:xfrm>
-          <a:prstGeom prst="rect">
-            <a:avLst/>
-          </a:prstGeom>
-          <a:noFill/>
-        </p:spPr>
-        <p:txBody>
-          <a:bodyPr wrap="none">
-            <a:spAutoFit/>
-          </a:bodyPr>
-          <a:lstStyle/>
-          <a:p>
-            <a:pPr>
-              <a:defRPr sz="1200">
-                <a:solidFill>
-                  <a:srgbClr val="4A5568"/>
-                </a:solidFill>
-                <a:latin typeface="Calibri"/>
-              </a:defRPr>
-            </a:pPr>
-            <a:r>
-              <a:t>Équipe 1 · Learning Analytics · Cloud Computing I  |  14/14</a:t>
+              <a:t>Équipe 1 · Avancement · PoC terminée  |  11/11</a:t>
             </a:r>
           </a:p>
         </p:txBody>
@@ -5269,7 +4348,7 @@
           <a:lstStyle/>
           <a:p>
             <a:pPr>
-              <a:defRPr sz="3000" b="1">
+              <a:defRPr sz="2800" b="1">
                 <a:solidFill>
                   <a:srgbClr val="FFFFFF"/>
                 </a:solidFill>
@@ -5277,7 +4356,7 @@
               </a:defRPr>
             </a:pPr>
             <a:r>
-              <a:t>Problématique</a:t>
+              <a:t>Message d’avancement</a:t>
             </a:r>
           </a:p>
         </p:txBody>
@@ -5290,7 +4369,7 @@
         </p:nvSpPr>
         <p:spPr>
           <a:xfrm>
-            <a:off x="822960" y="1737360"/>
+            <a:off x="822960" y="1691640"/>
             <a:ext cx="10515600" cy="4389120"/>
           </a:xfrm>
           <a:prstGeom prst="rect">
@@ -5308,7 +4387,7 @@
               <a:spcAft>
                 <a:spcPts val="1000"/>
               </a:spcAft>
-              <a:defRPr sz="2400">
+              <a:defRPr sz="2200">
                 <a:solidFill>
                   <a:srgbClr val="1A1A1A"/>
                 </a:solidFill>
@@ -5316,7 +4395,7 @@
               </a:defRPr>
             </a:pPr>
             <a:r>
-              <a:t>Traces d’apprentissage dispersées (LMS, quiz, vidéos)</a:t>
+              <a:t>Minimum demandé : problème + idée + début Docker</a:t>
             </a:r>
           </a:p>
           <a:p>
@@ -5324,7 +4403,7 @@
               <a:spcAft>
                 <a:spcPts val="1000"/>
               </a:spcAft>
-              <a:defRPr sz="2400">
+              <a:defRPr sz="2200">
                 <a:solidFill>
                   <a:srgbClr val="1A1A1A"/>
                 </a:solidFill>
@@ -5332,7 +4411,7 @@
               </a:defRPr>
             </a:pPr>
             <a:r>
-              <a:t>Décrochage souvent détecté trop tard</a:t>
+              <a:t>Notre avancement : la PoC complète fonctionne déjà</a:t>
             </a:r>
           </a:p>
           <a:p>
@@ -5340,7 +4419,7 @@
               <a:spcAft>
                 <a:spcPts val="1000"/>
               </a:spcAft>
-              <a:defRPr sz="2400">
+              <a:defRPr sz="2200">
                 <a:solidFill>
                   <a:srgbClr val="1A1A1A"/>
                 </a:solidFill>
@@ -5348,7 +4427,23 @@
               </a:defRPr>
             </a:pPr>
             <a:r>
-              <a:t>Peu d’actions guidées par la donnée pour les enseignants</a:t>
+              <a:t>Aujourd’hui : on montre le résultat technique</a:t>
+            </a:r>
+          </a:p>
+          <a:p>
+            <a:pPr>
+              <a:spcAft>
+                <a:spcPts val="1000"/>
+              </a:spcAft>
+              <a:defRPr sz="2200">
+                <a:solidFill>
+                  <a:srgbClr val="1A1A1A"/>
+                </a:solidFill>
+                <a:latin typeface="Calibri"/>
+              </a:defRPr>
+            </a:pPr>
+            <a:r>
+              <a:t>Suite : polish rapport / soutenance finale</a:t>
             </a:r>
           </a:p>
         </p:txBody>
@@ -5384,7 +4479,7 @@
               </a:defRPr>
             </a:pPr>
             <a:r>
-              <a:t>Équipe 1 · Learning Analytics · Cloud Computing I  |  1/14</a:t>
+              <a:t>Équipe 1 · Avancement · PoC terminée  |  1/11</a:t>
             </a:r>
           </a:p>
         </p:txBody>
@@ -5559,7 +4654,7 @@
           <a:lstStyle/>
           <a:p>
             <a:pPr>
-              <a:defRPr sz="3000" b="1">
+              <a:defRPr sz="2800" b="1">
                 <a:solidFill>
                   <a:srgbClr val="FFFFFF"/>
                 </a:solidFill>
@@ -5567,7 +4662,7 @@
               </a:defRPr>
             </a:pPr>
             <a:r>
-              <a:t>Objectif du service</a:t>
+              <a:t>Problématique</a:t>
             </a:r>
           </a:p>
         </p:txBody>
@@ -5580,7 +4675,7 @@
         </p:nvSpPr>
         <p:spPr>
           <a:xfrm>
-            <a:off x="822960" y="1737360"/>
+            <a:off x="822960" y="1691640"/>
             <a:ext cx="10515600" cy="4389120"/>
           </a:xfrm>
           <a:prstGeom prst="rect">
@@ -5598,7 +4693,7 @@
               <a:spcAft>
                 <a:spcPts val="1000"/>
               </a:spcAft>
-              <a:defRPr sz="2400">
+              <a:defRPr sz="2200">
                 <a:solidFill>
                   <a:srgbClr val="1A1A1A"/>
                 </a:solidFill>
@@ -5606,7 +4701,7 @@
               </a:defRPr>
             </a:pPr>
             <a:r>
-              <a:t>1. Collecter (xAPI / LRS)</a:t>
+              <a:t>Traces d’apprentissage dispersées (LMS, quiz, vidéos…)</a:t>
             </a:r>
           </a:p>
           <a:p>
@@ -5614,7 +4709,7 @@
               <a:spcAft>
                 <a:spcPts val="1000"/>
               </a:spcAft>
-              <a:defRPr sz="2400">
+              <a:defRPr sz="2200">
                 <a:solidFill>
                   <a:srgbClr val="1A1A1A"/>
                 </a:solidFill>
@@ -5622,7 +4717,7 @@
               </a:defRPr>
             </a:pPr>
             <a:r>
-              <a:t>2. Analyser (KPIs + machine learning)</a:t>
+              <a:t>Décrochage détecté trop tard</a:t>
             </a:r>
           </a:p>
           <a:p>
@@ -5630,7 +4725,7 @@
               <a:spcAft>
                 <a:spcPts val="1000"/>
               </a:spcAft>
-              <a:defRPr sz="2400">
+              <a:defRPr sz="2200">
                 <a:solidFill>
                   <a:srgbClr val="1A1A1A"/>
                 </a:solidFill>
@@ -5638,23 +4733,7 @@
               </a:defRPr>
             </a:pPr>
             <a:r>
-              <a:t>3. Recommander (remédiations)</a:t>
-            </a:r>
-          </a:p>
-          <a:p>
-            <a:pPr>
-              <a:spcAft>
-                <a:spcPts val="1000"/>
-              </a:spcAft>
-              <a:defRPr sz="2400">
-                <a:solidFill>
-                  <a:srgbClr val="1A1A1A"/>
-                </a:solidFill>
-                <a:latin typeface="Calibri"/>
-              </a:defRPr>
-            </a:pPr>
-            <a:r>
-              <a:t>4. Communiquer (dashboard + API)</a:t>
+              <a:t>Enseignants peu outillés pour agir avec la donnée</a:t>
             </a:r>
           </a:p>
         </p:txBody>
@@ -5690,7 +4769,7 @@
               </a:defRPr>
             </a:pPr>
             <a:r>
-              <a:t>Équipe 1 · Learning Analytics · Cloud Computing I  |  2/14</a:t>
+              <a:t>Équipe 1 · Avancement · PoC terminée  |  2/11</a:t>
             </a:r>
           </a:p>
         </p:txBody>
@@ -5865,7 +4944,7 @@
           <a:lstStyle/>
           <a:p>
             <a:pPr>
-              <a:defRPr sz="3000" b="1">
+              <a:defRPr sz="2800" b="1">
                 <a:solidFill>
                   <a:srgbClr val="FFFFFF"/>
                 </a:solidFill>
@@ -5873,7 +4952,7 @@
               </a:defRPr>
             </a:pPr>
             <a:r>
-              <a:t>Acteurs</a:t>
+              <a:t>Solution proposée</a:t>
             </a:r>
           </a:p>
         </p:txBody>
@@ -5886,7 +4965,7 @@
         </p:nvSpPr>
         <p:spPr>
           <a:xfrm>
-            <a:off x="822960" y="1737360"/>
+            <a:off x="822960" y="1691640"/>
             <a:ext cx="10515600" cy="4389120"/>
           </a:xfrm>
           <a:prstGeom prst="rect">
@@ -5904,7 +4983,7 @@
               <a:spcAft>
                 <a:spcPts val="1000"/>
               </a:spcAft>
-              <a:defRPr sz="2400">
+              <a:defRPr sz="2200">
                 <a:solidFill>
                   <a:srgbClr val="1A1A1A"/>
                 </a:solidFill>
@@ -5912,7 +4991,7 @@
               </a:defRPr>
             </a:pPr>
             <a:r>
-              <a:t>Enseignant → vue risque + actions</a:t>
+              <a:t>Service SaaS de Learning Analytics</a:t>
             </a:r>
           </a:p>
           <a:p>
@@ -5920,7 +4999,7 @@
               <a:spcAft>
                 <a:spcPts val="1000"/>
               </a:spcAft>
-              <a:defRPr sz="2400">
+              <a:defRPr sz="2200">
                 <a:solidFill>
                   <a:srgbClr val="1A1A1A"/>
                 </a:solidFill>
@@ -5928,7 +5007,7 @@
               </a:defRPr>
             </a:pPr>
             <a:r>
-              <a:t>Coordinateur → vue cohorte / cours</a:t>
+              <a:t>Collecte standard xAPI → entrepôt → analytics / ML</a:t>
             </a:r>
           </a:p>
           <a:p>
@@ -5936,7 +5015,7 @@
               <a:spcAft>
                 <a:spcPts val="1000"/>
               </a:spcAft>
-              <a:defRPr sz="2400">
+              <a:defRPr sz="2200">
                 <a:solidFill>
                   <a:srgbClr val="1A1A1A"/>
                 </a:solidFill>
@@ -5944,7 +5023,7 @@
               </a:defRPr>
             </a:pPr>
             <a:r>
-              <a:t>Apprenant → parcours adapté (indirect)</a:t>
+              <a:t>Dashboard : risque + remédiations pour l’enseignant</a:t>
             </a:r>
           </a:p>
           <a:p>
@@ -5952,7 +5031,7 @@
               <a:spcAft>
                 <a:spcPts val="1000"/>
               </a:spcAft>
-              <a:defRPr sz="2400">
+              <a:defRPr sz="2200">
                 <a:solidFill>
                   <a:srgbClr val="1A1A1A"/>
                 </a:solidFill>
@@ -5960,7 +5039,7 @@
               </a:defRPr>
             </a:pPr>
             <a:r>
-              <a:t>Provider UPPA/EVA → hébergement sécurisé</a:t>
+              <a:t>Déploiement private cloud EVA (UPPA)</a:t>
             </a:r>
           </a:p>
         </p:txBody>
@@ -5996,7 +5075,7 @@
               </a:defRPr>
             </a:pPr>
             <a:r>
-              <a:t>Équipe 1 · Learning Analytics · Cloud Computing I  |  3/14</a:t>
+              <a:t>Équipe 1 · Avancement · PoC terminée  |  3/11</a:t>
             </a:r>
           </a:p>
         </p:txBody>
@@ -6171,7 +5250,7 @@
           <a:lstStyle/>
           <a:p>
             <a:pPr>
-              <a:defRPr sz="3000" b="1">
+              <a:defRPr sz="2800" b="1">
                 <a:solidFill>
                   <a:srgbClr val="FFFFFF"/>
                 </a:solidFill>
@@ -6192,7 +5271,7 @@
         </p:nvSpPr>
         <p:spPr>
           <a:xfrm>
-            <a:off x="822960" y="1737360"/>
+            <a:off x="822960" y="1691640"/>
             <a:ext cx="10515600" cy="4389120"/>
           </a:xfrm>
           <a:prstGeom prst="rect">
@@ -6210,7 +5289,7 @@
               <a:spcAft>
                 <a:spcPts val="1000"/>
               </a:spcAft>
-              <a:defRPr sz="2400">
+              <a:defRPr sz="2200">
                 <a:solidFill>
                   <a:srgbClr val="1A1A1A"/>
                 </a:solidFill>
@@ -6226,7 +5305,7 @@
               <a:spcAft>
                 <a:spcPts val="1000"/>
               </a:spcAft>
-              <a:defRPr sz="2400">
+              <a:defRPr sz="2200">
                 <a:solidFill>
                   <a:srgbClr val="1A1A1A"/>
                 </a:solidFill>
@@ -6242,7 +5321,7 @@
               <a:spcAft>
                 <a:spcPts val="1000"/>
               </a:spcAft>
-              <a:defRPr sz="2400">
+              <a:defRPr sz="2200">
                 <a:solidFill>
                   <a:srgbClr val="1A1A1A"/>
                 </a:solidFill>
@@ -6258,7 +5337,7 @@
               <a:spcAft>
                 <a:spcPts val="1000"/>
               </a:spcAft>
-              <a:defRPr sz="2400">
+              <a:defRPr sz="2200">
                 <a:solidFill>
                   <a:srgbClr val="1A1A1A"/>
                 </a:solidFill>
@@ -6266,7 +5345,7 @@
               </a:defRPr>
             </a:pPr>
             <a:r>
-              <a:t>Accès : VPN + SSH</a:t>
+              <a:t>Consumer = enseignant · Provider = équipe / UPPA</a:t>
             </a:r>
           </a:p>
         </p:txBody>
@@ -6302,7 +5381,7 @@
               </a:defRPr>
             </a:pPr>
             <a:r>
-              <a:t>Équipe 1 · Learning Analytics · Cloud Computing I  |  4/14</a:t>
+              <a:t>Équipe 1 · Avancement · PoC terminée  |  4/11</a:t>
             </a:r>
           </a:p>
         </p:txBody>
@@ -6477,7 +5556,7 @@
           <a:lstStyle/>
           <a:p>
             <a:pPr>
-              <a:defRPr sz="3000" b="1">
+              <a:defRPr sz="2800" b="1">
                 <a:solidFill>
                   <a:srgbClr val="FFFFFF"/>
                 </a:solidFill>
@@ -6498,7 +5577,7 @@
         </p:nvSpPr>
         <p:spPr>
           <a:xfrm>
-            <a:off x="822960" y="1737360"/>
+            <a:off x="822960" y="1691640"/>
             <a:ext cx="10515600" cy="4389120"/>
           </a:xfrm>
           <a:prstGeom prst="rect">
@@ -6516,7 +5595,7 @@
               <a:spcAft>
                 <a:spcPts val="1000"/>
               </a:spcAft>
-              <a:defRPr sz="2400">
+              <a:defRPr sz="2200">
                 <a:solidFill>
                   <a:srgbClr val="1A1A1A"/>
                 </a:solidFill>
@@ -6532,7 +5611,7 @@
               <a:spcAft>
                 <a:spcPts val="1000"/>
               </a:spcAft>
-              <a:defRPr sz="2400">
+              <a:defRPr sz="2200">
                 <a:solidFill>
                   <a:srgbClr val="1A1A1A"/>
                 </a:solidFill>
@@ -6540,7 +5619,7 @@
               </a:defRPr>
             </a:pPr>
             <a:r>
-              <a:t>analytics-worker → tables analytics</a:t>
+              <a:t>analytics-worker (engagement + risque ML)</a:t>
             </a:r>
           </a:p>
           <a:p>
@@ -6548,7 +5627,7 @@
               <a:spcAft>
                 <a:spcPts val="1000"/>
               </a:spcAft>
-              <a:defRPr sz="2400">
+              <a:defRPr sz="2200">
                 <a:solidFill>
                   <a:srgbClr val="1A1A1A"/>
                 </a:solidFill>
@@ -6556,7 +5635,7 @@
               </a:defRPr>
             </a:pPr>
             <a:r>
-              <a:t>analytics-api → dashboard (nginx)</a:t>
+              <a:t>analytics-api → dashboard enseignants</a:t>
             </a:r>
           </a:p>
           <a:p>
@@ -6564,7 +5643,7 @@
               <a:spcAft>
                 <a:spcPts val="1000"/>
               </a:spcAft>
-              <a:defRPr sz="2400">
+              <a:defRPr sz="2200">
                 <a:solidFill>
                   <a:srgbClr val="1A1A1A"/>
                 </a:solidFill>
@@ -6608,7 +5687,7 @@
               </a:defRPr>
             </a:pPr>
             <a:r>
-              <a:t>Équipe 1 · Learning Analytics · Cloud Computing I  |  5/14</a:t>
+              <a:t>Équipe 1 · Avancement · PoC terminée  |  5/11</a:t>
             </a:r>
           </a:p>
         </p:txBody>
@@ -6783,7 +5862,7 @@
           <a:lstStyle/>
           <a:p>
             <a:pPr>
-              <a:defRPr sz="3000" b="1">
+              <a:defRPr sz="2800" b="1">
                 <a:solidFill>
                   <a:srgbClr val="FFFFFF"/>
                 </a:solidFill>
@@ -6804,7 +5883,7 @@
         </p:nvSpPr>
         <p:spPr>
           <a:xfrm>
-            <a:off x="822960" y="1737360"/>
+            <a:off x="822960" y="1691640"/>
             <a:ext cx="10515600" cy="4389120"/>
           </a:xfrm>
           <a:prstGeom prst="rect">
@@ -6822,7 +5901,7 @@
               <a:spcAft>
                 <a:spcPts val="1000"/>
               </a:spcAft>
-              <a:defRPr sz="2400">
+              <a:defRPr sz="2200">
                 <a:solidFill>
                   <a:srgbClr val="1A1A1A"/>
                 </a:solidFill>
@@ -6838,7 +5917,7 @@
               <a:spcAft>
                 <a:spcPts val="1000"/>
               </a:spcAft>
-              <a:defRPr sz="2400">
+              <a:defRPr sz="2200">
                 <a:solidFill>
                   <a:srgbClr val="1A1A1A"/>
                 </a:solidFill>
@@ -6846,7 +5925,7 @@
               </a:defRPr>
             </a:pPr>
             <a:r>
-              <a:t>Développé : LRS xAPI, générateur, worker ML, API BI, dashboard, tests</a:t>
+              <a:t>Développé : LRS xAPI, générateur, worker ML, API, dashboard</a:t>
             </a:r>
           </a:p>
           <a:p>
@@ -6854,7 +5933,7 @@
               <a:spcAft>
                 <a:spcPts val="1000"/>
               </a:spcAft>
-              <a:defRPr sz="2400">
+              <a:defRPr sz="2200">
                 <a:solidFill>
                   <a:srgbClr val="1A1A1A"/>
                 </a:solidFill>
@@ -6862,7 +5941,7 @@
               </a:defRPr>
             </a:pPr>
             <a:r>
-              <a:t>Consigne : ni from scratch, ni collage d’images</a:t>
+              <a:t>Conforme à la consigne : ni from scratch, ni collage d’images</a:t>
             </a:r>
           </a:p>
         </p:txBody>
@@ -6898,7 +5977,7 @@
               </a:defRPr>
             </a:pPr>
             <a:r>
-              <a:t>Équipe 1 · Learning Analytics · Cloud Computing I  |  6/14</a:t>
+              <a:t>Équipe 1 · Avancement · PoC terminée  |  6/11</a:t>
             </a:r>
           </a:p>
         </p:txBody>
@@ -7073,7 +6152,7 @@
           <a:lstStyle/>
           <a:p>
             <a:pPr>
-              <a:defRPr sz="3000" b="1">
+              <a:defRPr sz="2800" b="1">
                 <a:solidFill>
                   <a:srgbClr val="FFFFFF"/>
                 </a:solidFill>
@@ -7081,7 +6160,7 @@
               </a:defRPr>
             </a:pPr>
             <a:r>
-              <a:t>xAPI en bref</a:t>
+              <a:t>Ce qui tourne aujourd’hui</a:t>
             </a:r>
           </a:p>
         </p:txBody>
@@ -7094,7 +6173,7 @@
         </p:nvSpPr>
         <p:spPr>
           <a:xfrm>
-            <a:off x="822960" y="1737360"/>
+            <a:off x="822960" y="1691640"/>
             <a:ext cx="10515600" cy="4389120"/>
           </a:xfrm>
           <a:prstGeom prst="rect">
@@ -7112,7 +6191,7 @@
               <a:spcAft>
                 <a:spcPts val="1000"/>
               </a:spcAft>
-              <a:defRPr sz="2400">
+              <a:defRPr sz="2200">
                 <a:solidFill>
                   <a:srgbClr val="1A1A1A"/>
                 </a:solidFill>
@@ -7120,7 +6199,7 @@
               </a:defRPr>
             </a:pPr>
             <a:r>
-              <a:t>Standard JSON : qui a fait quoi, quand, sur quoi</a:t>
+              <a:t>Stack Compose multi-conteneurs opérationnelle</a:t>
             </a:r>
           </a:p>
           <a:p>
@@ -7128,7 +6207,7 @@
               <a:spcAft>
                 <a:spcPts val="1000"/>
               </a:spcAft>
-              <a:defRPr sz="2400">
+              <a:defRPr sz="2200">
                 <a:solidFill>
                   <a:srgbClr val="1A1A1A"/>
                 </a:solidFill>
@@ -7136,7 +6215,7 @@
               </a:defRPr>
             </a:pPr>
             <a:r>
-              <a:t>LRS = entrepôt normé de statements</a:t>
+              <a:t>~2000–3000+ statements xAPI · 25 apprenants simulés</a:t>
             </a:r>
           </a:p>
           <a:p>
@@ -7144,7 +6223,7 @@
               <a:spcAft>
                 <a:spcPts val="1000"/>
               </a:spcAft>
-              <a:defRPr sz="2400">
+              <a:defRPr sz="2200">
                 <a:solidFill>
                   <a:srgbClr val="1A1A1A"/>
                 </a:solidFill>
@@ -7152,7 +6231,39 @@
               </a:defRPr>
             </a:pPr>
             <a:r>
-              <a:t>Interopérabilité entre outils éducatifs</a:t>
+              <a:t>Dashboard : KPIs, risque, remédiations</a:t>
+            </a:r>
+          </a:p>
+          <a:p>
+            <a:pPr>
+              <a:spcAft>
+                <a:spcPts val="1000"/>
+              </a:spcAft>
+              <a:defRPr sz="2200">
+                <a:solidFill>
+                  <a:srgbClr val="1A1A1A"/>
+                </a:solidFill>
+                <a:latin typeface="Calibri"/>
+              </a:defRPr>
+            </a:pPr>
+            <a:r>
+              <a:t>Smoke test automatisé : PASSED</a:t>
+            </a:r>
+          </a:p>
+          <a:p>
+            <a:pPr>
+              <a:spcAft>
+                <a:spcPts val="1000"/>
+              </a:spcAft>
+              <a:defRPr sz="2200">
+                <a:solidFill>
+                  <a:srgbClr val="1A1A1A"/>
+                </a:solidFill>
+                <a:latin typeface="Calibri"/>
+              </a:defRPr>
+            </a:pPr>
+            <a:r>
+              <a:t>Hub Docker : images poussées (edouardclemenceau/...)</a:t>
             </a:r>
           </a:p>
         </p:txBody>
@@ -7188,7 +6299,7 @@
               </a:defRPr>
             </a:pPr>
             <a:r>
-              <a:t>Équipe 1 · Learning Analytics · Cloud Computing I  |  7/14</a:t>
+              <a:t>Équipe 1 · Avancement · PoC terminée  |  7/11</a:t>
             </a:r>
           </a:p>
         </p:txBody>
@@ -7363,7 +6474,7 @@
           <a:lstStyle/>
           <a:p>
             <a:pPr>
-              <a:defRPr sz="3000" b="1">
+              <a:defRPr sz="2800" b="1">
                 <a:solidFill>
                   <a:srgbClr val="FFFFFF"/>
                 </a:solidFill>
@@ -7371,7 +6482,7 @@
               </a:defRPr>
             </a:pPr>
             <a:r>
-              <a:t>Analytics &amp; ML</a:t>
+              <a:t>Démo</a:t>
             </a:r>
           </a:p>
         </p:txBody>
@@ -7384,7 +6495,7 @@
         </p:nvSpPr>
         <p:spPr>
           <a:xfrm>
-            <a:off x="822960" y="1737360"/>
+            <a:off x="822960" y="1691640"/>
             <a:ext cx="10515600" cy="4389120"/>
           </a:xfrm>
           <a:prstGeom prst="rect">
@@ -7402,7 +6513,7 @@
               <a:spcAft>
                 <a:spcPts val="1000"/>
               </a:spcAft>
-              <a:defRPr sz="2400">
+              <a:defRPr sz="2200">
                 <a:solidFill>
                   <a:srgbClr val="1A1A1A"/>
                 </a:solidFill>
@@ -7410,7 +6521,7 @@
               </a:defRPr>
             </a:pPr>
             <a:r>
-              <a:t>Engagement : activité + scores quiz simulés</a:t>
+              <a:t>Dashboard : http://localhost:8300</a:t>
             </a:r>
           </a:p>
           <a:p>
@@ -7418,7 +6529,7 @@
               <a:spcAft>
                 <a:spcPts val="1000"/>
               </a:spcAft>
-              <a:defRPr sz="2400">
+              <a:defRPr sz="2200">
                 <a:solidFill>
                   <a:srgbClr val="1A1A1A"/>
                 </a:solidFill>
@@ -7426,7 +6537,7 @@
               </a:defRPr>
             </a:pPr>
             <a:r>
-              <a:t>Risque : Isolation Forest + score d’engagement</a:t>
+              <a:t>API : http://localhost:8210/api/overview</a:t>
             </a:r>
           </a:p>
           <a:p>
@@ -7434,7 +6545,7 @@
               <a:spcAft>
                 <a:spcPts val="1000"/>
               </a:spcAft>
-              <a:defRPr sz="2400">
+              <a:defRPr sz="2200">
                 <a:solidFill>
                   <a:srgbClr val="1A1A1A"/>
                 </a:solidFill>
@@ -7442,7 +6553,23 @@
               </a:defRPr>
             </a:pPr>
             <a:r>
-              <a:t>Remédiation : conseils actionnables par niveau de risque</a:t>
+              <a:t>EVA (VPN) : http://10.3.16.179:8300</a:t>
+            </a:r>
+          </a:p>
+          <a:p>
+            <a:pPr>
+              <a:spcAft>
+                <a:spcPts val="1000"/>
+              </a:spcAft>
+              <a:defRPr sz="2200">
+                <a:solidFill>
+                  <a:srgbClr val="1A1A1A"/>
+                </a:solidFill>
+                <a:latin typeface="Calibri"/>
+              </a:defRPr>
+            </a:pPr>
+            <a:r>
+              <a:t>→ Montrer les apprenants à risque + remédiations</a:t>
             </a:r>
           </a:p>
         </p:txBody>
@@ -7478,7 +6605,7 @@
               </a:defRPr>
             </a:pPr>
             <a:r>
-              <a:t>Équipe 1 · Learning Analytics · Cloud Computing I  |  8/14</a:t>
+              <a:t>Équipe 1 · Avancement · PoC terminée  |  8/11</a:t>
             </a:r>
           </a:p>
         </p:txBody>

</xml_diff>